<commit_message>
docs: v2.0 — regenerate all three manuals to current reality
Architecture, User and Operation manuals (plus decks and diagrams)
updated from the stale 1 Aug v1.0: 12 pages + contact.php, the copy
overhaul and positioning, service detail pages, four blog articles,
the services cost estimator with its quote-to-contact flow, the
context-carrying CTAs, the apps.p3mai.com front door (six apps), the
contact-mail pipeline operations, the corrected publish allow-list
(now includes service pages, articles, contact.php and the tile
icons), and the CDN cache-busting discipline including the
never-probe-pre-deploy rule.

Co-Authored-By: Claude Fable 5 <noreply@anthropic.com>
</commit_message>
<xml_diff>
--- a/docs/01_Architecture_and_Design_Summary.pptx
+++ b/docs/01_Architecture_and_Design_Summary.pptx
@@ -13,7 +13,6 @@
     <p:sldId id="261" r:id="rId12"/>
     <p:sldId id="262" r:id="rId13"/>
     <p:sldId id="263" r:id="rId14"/>
-    <p:sldId id="264" r:id="rId15"/>
   </p:sldIdLst>
   <p:sldSz cx="12191695" cy="6858000" type="screen4x3"/>
   <p:notesSz cx="6858000" cy="9144000"/>
@@ -3305,7 +3304,7 @@
                 </a:solidFill>
                 <a:latin typeface="Segoe UI"/>
               </a:rPr>
-              <a:t>Structure &amp; design of the P3MAI website — summary</a:t>
+              <a:t>Structure &amp; design of the P3MAI website — summary (v2.0)</a:t>
             </a:r>
           </a:p>
         </p:txBody>
@@ -3493,7 +3492,7 @@
                 </a:solidFill>
                 <a:latin typeface="Segoe UI"/>
               </a:rPr>
-              <a:t>Simple, fast, robust.</a:t>
+              <a:t>“AI-Enabled · Sovereign · Safe · Proven.”</a:t>
             </a:r>
           </a:p>
         </p:txBody>
@@ -3535,7 +3534,7 @@
                 </a:solidFill>
                 <a:latin typeface="Segoe UI"/>
               </a:rPr>
-              <a:t>•  Public business site for P3MAI.</a:t>
+              <a:t>•  Public business site for P3MAI — Board-level positioning.</a:t>
             </a:r>
           </a:p>
           <a:p>
@@ -3554,7 +3553,7 @@
                 </a:solidFill>
                 <a:latin typeface="Segoe UI"/>
               </a:rPr>
-              <a:t>•  Five pages + a standalone Project Cost Estimator.</a:t>
+              <a:t>•  12 pages + 2 estimators + ONE PHP endpoint (contact.php).</a:t>
             </a:r>
           </a:p>
           <a:p>
@@ -3573,7 +3572,7 @@
                 </a:solidFill>
                 <a:latin typeface="Segoe UI"/>
               </a:rPr>
-              <a:t>•  Hand-built static site — HTML/CSS/JS, no framework, no build.</a:t>
+              <a:t>•  Hand-built HTML/CSS/JS — no framework, no build step.</a:t>
             </a:r>
           </a:p>
         </p:txBody>
@@ -3803,7 +3802,7 @@
                 </a:solidFill>
                 <a:latin typeface="Segoe UI"/>
               </a:rPr>
-              <a:t>Home links five pages; Services links the two P3MAI apps.</a:t>
+              <a:t>Services opens 3 detail pages, the estimator and 6 live apps; Blog opens 4 full articles.</a:t>
             </a:r>
           </a:p>
         </p:txBody>
@@ -3824,8 +3823,8 @@
         </p:blipFill>
         <p:spPr>
           <a:xfrm>
-            <a:off x="2581737" y="2057400"/>
-            <a:ext cx="7028220" cy="4297680"/>
+            <a:off x="2573028" y="2057400"/>
+            <a:ext cx="7045638" cy="4297680"/>
           </a:xfrm>
           <a:prstGeom prst="rect">
             <a:avLst/>
@@ -4030,7 +4029,7 @@
         </p:nvGraphicFramePr>
         <p:xfrm>
           <a:off x="566928" y="1691640"/>
-          <a:ext cx="11064240" cy="2286000"/>
+          <a:ext cx="11064240" cy="2743200"/>
         </p:xfrm>
         <a:graphic>
           <a:graphicData uri="http://schemas.openxmlformats.org/drawingml/2006/table">
@@ -4123,7 +4122,7 @@
                           </a:solidFill>
                           <a:latin typeface="Segoe UI"/>
                         </a:rPr>
-                        <a:t>HTML5 · one CSS design system</a:t>
+                        <a:t>HTML5 · one CSS design system (?v=N versioned)</a:t>
                       </a:r>
                     </a:p>
                   </a:txBody>
@@ -4169,7 +4168,7 @@
                           </a:solidFill>
                           <a:latin typeface="Segoe UI"/>
                         </a:rPr>
-                        <a:t>Vanilla JS (script.js) — no framework/build</a:t>
+                        <a:t>Vanilla JS (script.js ?v=N) — env-aware links, context CTAs</a:t>
                       </a:r>
                     </a:p>
                   </a:txBody>
@@ -4193,7 +4192,7 @@
                           </a:solidFill>
                           <a:latin typeface="Segoe UI"/>
                         </a:rPr>
-                        <a:t>Brand</a:t>
+                        <a:t>Server-side</a:t>
                       </a:r>
                     </a:p>
                   </a:txBody>
@@ -4215,7 +4214,7 @@
                           </a:solidFill>
                           <a:latin typeface="Segoe UI"/>
                         </a:rPr>
-                        <a:t>Navy #0B2545 · gold #C9A227 · Poppins · pyramid logo</a:t>
+                        <a:t>contact.php only — the mail handler</a:t>
                       </a:r>
                     </a:p>
                   </a:txBody>
@@ -4239,7 +4238,7 @@
                           </a:solidFill>
                           <a:latin typeface="Segoe UI"/>
                         </a:rPr>
-                        <a:t>Hosting</a:t>
+                        <a:t>Brand</a:t>
                       </a:r>
                     </a:p>
                   </a:txBody>
@@ -4261,13 +4260,59 @@
                           </a:solidFill>
                           <a:latin typeface="Segoe UI"/>
                         </a:rPr>
-                        <a:t>Rise (UK shared cPanel/FTP)</a:t>
+                        <a:t>Navy #0B2545 · gold #C9A227 · Poppins · two-tone P3M+AI wordmark</a:t>
                       </a:r>
                     </a:p>
                   </a:txBody>
                   <a:tcPr>
                     <a:solidFill>
                       <a:srgbClr val="F6F7F9"/>
+                    </a:solidFill>
+                  </a:tcPr>
+                </a:tc>
+              </a:tr>
+              <a:tr h="457200">
+                <a:tc>
+                  <a:txBody>
+                    <a:bodyPr wrap="square"/>
+                    <a:lstStyle/>
+                    <a:p>
+                      <a:r>
+                        <a:rPr sz="1100">
+                          <a:solidFill>
+                            <a:srgbClr val="1C2B3A"/>
+                          </a:solidFill>
+                          <a:latin typeface="Segoe UI"/>
+                        </a:rPr>
+                        <a:t>Hosting</a:t>
+                      </a:r>
+                    </a:p>
+                  </a:txBody>
+                  <a:tcPr>
+                    <a:solidFill>
+                      <a:srgbClr val="FFFFFF"/>
+                    </a:solidFill>
+                  </a:tcPr>
+                </a:tc>
+                <a:tc>
+                  <a:txBody>
+                    <a:bodyPr wrap="square"/>
+                    <a:lstStyle/>
+                    <a:p>
+                      <a:r>
+                        <a:rPr sz="1100">
+                          <a:solidFill>
+                            <a:srgbClr val="1C2B3A"/>
+                          </a:solidFill>
+                          <a:latin typeface="Segoe UI"/>
+                        </a:rPr>
+                        <a:t>Rise (UK cPanel/FTP) behind StackCDN</a:t>
+                      </a:r>
+                    </a:p>
+                  </a:txBody>
+                  <a:tcPr>
+                    <a:solidFill>
+                      <a:srgbClr val="FFFFFF"/>
                     </a:solidFill>
                   </a:tcPr>
                 </a:tc>
@@ -4501,7 +4546,7 @@
                 </a:solidFill>
                 <a:latin typeface="Segoe UI"/>
               </a:rPr>
-              <a:t>•  Env-aware app links (localhost in dev, live domain in prod).</a:t>
+              <a:t>•  Env-aware app links — six buttons swap to apps.p3mai.com/&lt;slug&gt; in prod.</a:t>
             </a:r>
           </a:p>
           <a:p>
@@ -4520,7 +4565,7 @@
                 </a:solidFill>
                 <a:latin typeface="Segoe UI"/>
               </a:rPr>
-              <a:t>•  Page-transition overlay; responsive hamburger nav.</a:t>
+              <a:t>•  Context CTAs: ?interest= (service) and ?details= (estimator basket) prefill the contact form.</a:t>
             </a:r>
           </a:p>
           <a:p>
@@ -4539,7 +4584,26 @@
                 </a:solidFill>
                 <a:latin typeface="Segoe UI"/>
               </a:rPr>
-              <a:t>•  Reveal-on-scroll; contact-form validation; smooth scroll.</a:t>
+              <a:t>•  Real form submission via fetch → contact.php → drcolvin@p3mai.com.</a:t>
+            </a:r>
+          </a:p>
+          <a:p>
+            <a:pPr algn="l">
+              <a:spcBef>
+                <a:spcPts val="0"/>
+              </a:spcBef>
+              <a:spcAft>
+                <a:spcPts val="1200"/>
+              </a:spcAft>
+            </a:pPr>
+            <a:r>
+              <a:rPr sz="1700" b="0">
+                <a:solidFill>
+                  <a:srgbClr val="1C2B3A"/>
+                </a:solidFill>
+                <a:latin typeface="Segoe UI"/>
+              </a:rPr>
+              <a:t>•  Page transitions, hamburger nav, reveal-on-scroll, validation.</a:t>
             </a:r>
           </a:p>
         </p:txBody>
@@ -4769,7 +4833,7 @@
                 </a:solidFill>
                 <a:latin typeface="Segoe UI"/>
               </a:rPr>
-              <a:t>Publish approved files by FTP into Rise public_html.</a:t>
+              <a:t>Rise + StackCDN for the site; Render front door for the apps; PHP mail pipeline.</a:t>
             </a:r>
           </a:p>
         </p:txBody>
@@ -4937,7 +5001,7 @@
                 </a:solidFill>
                 <a:latin typeface="Segoe UI Semibold"/>
               </a:rPr>
-              <a:t>Integrations</a:t>
+              <a:t>Key design decisions</a:t>
             </a:r>
           </a:p>
         </p:txBody>
@@ -4986,274 +5050,6 @@
           </a:p>
         </p:txBody>
       </p:sp>
-      <p:sp>
-        <p:nvSpPr>
-          <p:cNvPr id="4" name="TextBox 3"/>
-          <p:cNvSpPr txBox="1"/>
-          <p:nvPr/>
-        </p:nvSpPr>
-        <p:spPr>
-          <a:xfrm>
-            <a:off x="640080" y="1600200"/>
-            <a:ext cx="10972800" cy="4251960"/>
-          </a:xfrm>
-          <a:prstGeom prst="rect">
-            <a:avLst/>
-          </a:prstGeom>
-          <a:noFill/>
-        </p:spPr>
-        <p:txBody>
-          <a:bodyPr wrap="square" anchor="t">
-            <a:spAutoFit/>
-          </a:bodyPr>
-          <a:lstStyle/>
-          <a:p>
-            <a:pPr algn="l">
-              <a:spcBef>
-                <a:spcPts val="0"/>
-              </a:spcBef>
-              <a:spcAft>
-                <a:spcPts val="1200"/>
-              </a:spcAft>
-            </a:pPr>
-            <a:r>
-              <a:rPr sz="1700" b="0">
-                <a:solidFill>
-                  <a:srgbClr val="1C2B3A"/>
-                </a:solidFill>
-                <a:latin typeface="Segoe UI"/>
-              </a:rPr>
-              <a:t>•  Services page → PMO Service (Example) and PRINCE2 Method Map.</a:t>
-            </a:r>
-          </a:p>
-          <a:p>
-            <a:pPr algn="l">
-              <a:spcBef>
-                <a:spcPts val="0"/>
-              </a:spcBef>
-              <a:spcAft>
-                <a:spcPts val="1200"/>
-              </a:spcAft>
-            </a:pPr>
-            <a:r>
-              <a:rPr sz="1700" b="0">
-                <a:solidFill>
-                  <a:srgbClr val="1C2B3A"/>
-                </a:solidFill>
-                <a:latin typeface="Segoe UI"/>
-              </a:rPr>
-              <a:t>•  Both env-aware; both link back to the site.</a:t>
-            </a:r>
-          </a:p>
-          <a:p>
-            <a:pPr algn="l">
-              <a:spcBef>
-                <a:spcPts val="0"/>
-              </a:spcBef>
-              <a:spcAft>
-                <a:spcPts val="1200"/>
-              </a:spcAft>
-            </a:pPr>
-            <a:r>
-              <a:rPr sz="1700" b="0">
-                <a:solidFill>
-                  <a:srgbClr val="1C2B3A"/>
-                </a:solidFill>
-                <a:latin typeface="Segoe UI"/>
-              </a:rPr>
-              <a:t>•  Cost estimator directs enquiries to hello@P3MAI.com.</a:t>
-            </a:r>
-          </a:p>
-        </p:txBody>
-      </p:sp>
-      <p:sp>
-        <p:nvSpPr>
-          <p:cNvPr id="5" name="TextBox 4"/>
-          <p:cNvSpPr txBox="1"/>
-          <p:nvPr/>
-        </p:nvSpPr>
-        <p:spPr>
-          <a:xfrm>
-            <a:off x="320040" y="6419088"/>
-            <a:ext cx="3657600" cy="365760"/>
-          </a:xfrm>
-          <a:prstGeom prst="rect">
-            <a:avLst/>
-          </a:prstGeom>
-          <a:noFill/>
-        </p:spPr>
-        <p:txBody>
-          <a:bodyPr wrap="square" anchor="t">
-            <a:spAutoFit/>
-          </a:bodyPr>
-          <a:lstStyle/>
-          <a:p>
-            <a:pPr algn="l">
-              <a:spcBef>
-                <a:spcPts val="0"/>
-              </a:spcBef>
-              <a:spcAft>
-                <a:spcPts val="600"/>
-              </a:spcAft>
-            </a:pPr>
-            <a:r>
-              <a:rPr sz="900" b="1">
-                <a:solidFill>
-                  <a:srgbClr val="A8841C"/>
-                </a:solidFill>
-                <a:latin typeface="Segoe UI"/>
-              </a:rPr>
-              <a:t>OFFICIAL</a:t>
-            </a:r>
-          </a:p>
-        </p:txBody>
-      </p:sp>
-      <p:sp>
-        <p:nvSpPr>
-          <p:cNvPr id="6" name="TextBox 5"/>
-          <p:cNvSpPr txBox="1"/>
-          <p:nvPr/>
-        </p:nvSpPr>
-        <p:spPr>
-          <a:xfrm>
-            <a:off x="10789920" y="6419088"/>
-            <a:ext cx="1097280" cy="365760"/>
-          </a:xfrm>
-          <a:prstGeom prst="rect">
-            <a:avLst/>
-          </a:prstGeom>
-          <a:noFill/>
-        </p:spPr>
-        <p:txBody>
-          <a:bodyPr wrap="square" anchor="t">
-            <a:spAutoFit/>
-          </a:bodyPr>
-          <a:lstStyle/>
-          <a:p>
-            <a:pPr algn="r">
-              <a:spcBef>
-                <a:spcPts val="0"/>
-              </a:spcBef>
-              <a:spcAft>
-                <a:spcPts val="600"/>
-              </a:spcAft>
-            </a:pPr>
-            <a:r>
-              <a:rPr sz="900" b="0">
-                <a:solidFill>
-                  <a:srgbClr val="5B6675"/>
-                </a:solidFill>
-                <a:latin typeface="Segoe UI"/>
-              </a:rPr>
-              <a:t>DOC-01  ·  7</a:t>
-            </a:r>
-          </a:p>
-        </p:txBody>
-      </p:sp>
-    </p:spTree>
-  </p:cSld>
-  <p:clrMapOvr>
-    <a:masterClrMapping/>
-  </p:clrMapOvr>
-</p:sld>
-</file>
-
-<file path=ppt/slides/slide8.xml><?xml version="1.0" encoding="utf-8"?>
-<p:sld xmlns:a="http://schemas.openxmlformats.org/drawingml/2006/main" xmlns:p="http://schemas.openxmlformats.org/presentationml/2006/main" xmlns:r="http://schemas.openxmlformats.org/officeDocument/2006/relationships">
-  <p:cSld>
-    <p:spTree>
-      <p:nvGrpSpPr>
-        <p:cNvPr id="1" name=""/>
-        <p:cNvGrpSpPr/>
-        <p:nvPr/>
-      </p:nvGrpSpPr>
-      <p:grpSpPr/>
-      <p:sp>
-        <p:nvSpPr>
-          <p:cNvPr id="2" name="TextBox 1"/>
-          <p:cNvSpPr txBox="1"/>
-          <p:nvPr/>
-        </p:nvSpPr>
-        <p:spPr>
-          <a:xfrm>
-            <a:off x="548640" y="411480"/>
-            <a:ext cx="10972800" cy="914400"/>
-          </a:xfrm>
-          <a:prstGeom prst="rect">
-            <a:avLst/>
-          </a:prstGeom>
-          <a:noFill/>
-        </p:spPr>
-        <p:txBody>
-          <a:bodyPr wrap="square" anchor="t">
-            <a:spAutoFit/>
-          </a:bodyPr>
-          <a:lstStyle/>
-          <a:p>
-            <a:pPr algn="l">
-              <a:spcBef>
-                <a:spcPts val="0"/>
-              </a:spcBef>
-              <a:spcAft>
-                <a:spcPts val="600"/>
-              </a:spcAft>
-            </a:pPr>
-            <a:r>
-              <a:rPr sz="2600" b="1">
-                <a:solidFill>
-                  <a:srgbClr val="0B2545"/>
-                </a:solidFill>
-                <a:latin typeface="Segoe UI Semibold"/>
-              </a:rPr>
-              <a:t>Key design decisions</a:t>
-            </a:r>
-          </a:p>
-        </p:txBody>
-      </p:sp>
-      <p:sp>
-        <p:nvSpPr>
-          <p:cNvPr id="3" name="Rectangle 2"/>
-          <p:cNvSpPr/>
-          <p:nvPr/>
-        </p:nvSpPr>
-        <p:spPr>
-          <a:xfrm>
-            <a:off x="566928" y="1207008"/>
-            <a:ext cx="2926080" cy="38100"/>
-          </a:xfrm>
-          <a:prstGeom prst="rect">
-            <a:avLst/>
-          </a:prstGeom>
-          <a:solidFill>
-            <a:srgbClr val="C9A227"/>
-          </a:solidFill>
-          <a:ln>
-            <a:noFill/>
-          </a:ln>
-          <a:effectLst/>
-        </p:spPr>
-        <p:style>
-          <a:lnRef idx="1">
-            <a:schemeClr val="accent1"/>
-          </a:lnRef>
-          <a:fillRef idx="3">
-            <a:schemeClr val="accent1"/>
-          </a:fillRef>
-          <a:effectRef idx="2">
-            <a:schemeClr val="accent1"/>
-          </a:effectRef>
-          <a:fontRef idx="minor">
-            <a:schemeClr val="lt1"/>
-          </a:fontRef>
-        </p:style>
-        <p:txBody>
-          <a:bodyPr rtlCol="0" anchor="ctr"/>
-          <a:lstStyle/>
-          <a:p>
-            <a:pPr algn="ctr"/>
-          </a:p>
-        </p:txBody>
-      </p:sp>
       <p:graphicFrame>
         <p:nvGraphicFramePr>
           <p:cNvPr id="4" name="Table 3"/>
@@ -5264,7 +5060,7 @@
         </p:nvGraphicFramePr>
         <p:xfrm>
           <a:off x="566928" y="1691640"/>
-          <a:ext cx="11064240" cy="2286000"/>
+          <a:ext cx="11064240" cy="2743200"/>
         </p:xfrm>
         <a:graphic>
           <a:graphicData uri="http://schemas.openxmlformats.org/drawingml/2006/table">
@@ -5335,7 +5131,7 @@
                           </a:solidFill>
                           <a:latin typeface="Segoe UI"/>
                         </a:rPr>
-                        <a:t>Static, no framework/build</a:t>
+                        <a:t>Static + one PHP endpoint</a:t>
                       </a:r>
                     </a:p>
                   </a:txBody>
@@ -5357,7 +5153,7 @@
                           </a:solidFill>
                           <a:latin typeface="Segoe UI"/>
                         </a:rPr>
-                        <a:t>Fast, robust, trivially hostable</a:t>
+                        <a:t>Fast, robust; email needs exactly one server file</a:t>
                       </a:r>
                     </a:p>
                   </a:txBody>
@@ -5427,7 +5223,7 @@
                           </a:solidFill>
                           <a:latin typeface="Segoe UI"/>
                         </a:rPr>
-                        <a:t>Env-aware links in JS</a:t>
+                        <a:t>Context-carrying CTAs</a:t>
                       </a:r>
                     </a:p>
                   </a:txBody>
@@ -5449,7 +5245,7 @@
                           </a:solidFill>
                           <a:latin typeface="Segoe UI"/>
                         </a:rPr>
-                        <a:t>Cross-links work in dev and prod</a:t>
+                        <a:t>Every enquiry arrives naming its origin</a:t>
                       </a:r>
                     </a:p>
                   </a:txBody>
@@ -5473,7 +5269,7 @@
                           </a:solidFill>
                           <a:latin typeface="Segoe UI"/>
                         </a:rPr>
-                        <a:t>No fabricated content</a:t>
+                        <a:t>?v=N asset versioning</a:t>
                       </a:r>
                     </a:p>
                   </a:txBody>
@@ -5495,7 +5291,7 @@
                           </a:solidFill>
                           <a:latin typeface="Segoe UI"/>
                         </a:rPr>
-                        <a:t>Everything grounded in the real CV</a:t>
+                        <a:t>StackCDN caches by exact URL</a:t>
                       </a:r>
                     </a:p>
                   </a:txBody>
@@ -5506,6 +5302,52 @@
                   </a:tcPr>
                 </a:tc>
               </a:tr>
+              <a:tr h="457200">
+                <a:tc>
+                  <a:txBody>
+                    <a:bodyPr wrap="square"/>
+                    <a:lstStyle/>
+                    <a:p>
+                      <a:r>
+                        <a:rPr sz="1100">
+                          <a:solidFill>
+                            <a:srgbClr val="1C2B3A"/>
+                          </a:solidFill>
+                          <a:latin typeface="Segoe UI"/>
+                        </a:rPr>
+                        <a:t>No fabricated content</a:t>
+                      </a:r>
+                    </a:p>
+                  </a:txBody>
+                  <a:tcPr>
+                    <a:solidFill>
+                      <a:srgbClr val="FFFFFF"/>
+                    </a:solidFill>
+                  </a:tcPr>
+                </a:tc>
+                <a:tc>
+                  <a:txBody>
+                    <a:bodyPr wrap="square"/>
+                    <a:lstStyle/>
+                    <a:p>
+                      <a:r>
+                        <a:rPr sz="1100">
+                          <a:solidFill>
+                            <a:srgbClr val="1C2B3A"/>
+                          </a:solidFill>
+                          <a:latin typeface="Segoe UI"/>
+                        </a:rPr>
+                        <a:t>Grounded in the real CV; testimonials dormant until real</a:t>
+                      </a:r>
+                    </a:p>
+                  </a:txBody>
+                  <a:tcPr>
+                    <a:solidFill>
+                      <a:srgbClr val="FFFFFF"/>
+                    </a:solidFill>
+                  </a:tcPr>
+                </a:tc>
+              </a:tr>
             </a:tbl>
           </a:graphicData>
         </a:graphic>
@@ -5589,7 +5431,7 @@
                 </a:solidFill>
                 <a:latin typeface="Segoe UI"/>
               </a:rPr>
-              <a:t>DOC-01  ·  8</a:t>
+              <a:t>DOC-01  ·  7</a:t>
             </a:r>
           </a:p>
         </p:txBody>
@@ -5602,7 +5444,7 @@
 </p:sld>
 </file>
 
-<file path=ppt/slides/slide9.xml><?xml version="1.0" encoding="utf-8"?>
+<file path=ppt/slides/slide8.xml><?xml version="1.0" encoding="utf-8"?>
 <p:sld xmlns:a="http://schemas.openxmlformats.org/drawingml/2006/main" xmlns:p="http://schemas.openxmlformats.org/presentationml/2006/main" xmlns:r="http://schemas.openxmlformats.org/officeDocument/2006/relationships">
   <p:cSld>
     <p:spTree>
@@ -5735,7 +5577,7 @@
                 </a:solidFill>
                 <a:latin typeface="Segoe UI"/>
               </a:rPr>
-              <a:t>•  Switch the Method Map link to prince2.p3mai.com once DNS resolves.</a:t>
+              <a:t>•  Activate testimonials when real quotes land (MKT-08) → CTA pivot (MKT-09).</a:t>
             </a:r>
           </a:p>
           <a:p>
@@ -5754,7 +5596,7 @@
                 </a:solidFill>
                 <a:latin typeface="Segoe UI"/>
               </a:rPr>
-              <a:t>•  More blog content; optional analytics.</a:t>
+              <a:t>•  Analytics + email capture (MKT-01/02) — the funnel runs unmeasured today.</a:t>
             </a:r>
           </a:p>
         </p:txBody>
@@ -5838,7 +5680,7 @@
                 </a:solidFill>
                 <a:latin typeface="Segoe UI"/>
               </a:rPr>
-              <a:t>DOC-01  ·  9</a:t>
+              <a:t>DOC-01  ·  8</a:t>
             </a:r>
           </a:p>
         </p:txBody>

</xml_diff>